<commit_message>
Add canvas pan/resize, tree re-parenting, and TTA CSV export.
- HTA canvas: Space+drag pan, draggable split gutter (persisted in
  localStorage), viewport wrapper
- Arrow keys reorder siblings when selected, walk the tree when hovering;
  left/right outdent/indent the selected task
- TTA rows now always cover every task (ensureTtaCoversAllTasks) and are
  sorted in tree order; External Error Mode is a dropdown
- Unified undo/redo across tree state and text panel
- Export CSV writes BOM-prefixed UTF-8 with a tab-indented Outline column
  for Excel / SmartArt
- Rewrite README around HTA.html as the primary editor; add electric-kettle
  and Gemini-generated example data
- Extend smoke tests to cover the new DOM ids, actions, and functions

Co-Authored-By: Claude Opus 5 (1M context) <noreply@anthropic.com>
</commit_message>
<xml_diff>
--- a/HTA_design_notes.pptx
+++ b/HTA_design_notes.pptx
@@ -9,7 +9,11 @@
     <p:sldId id="257" r:id="rId3"/>
     <p:sldId id="258" r:id="rId4"/>
     <p:sldId id="259" r:id="rId5"/>
-    <p:sldId id="260" r:id="rId6"/>
+    <p:sldId id="261" r:id="rId6"/>
+    <p:sldId id="262" r:id="rId7"/>
+    <p:sldId id="263" r:id="rId8"/>
+    <p:sldId id="264" r:id="rId9"/>
+    <p:sldId id="265" r:id="rId10"/>
   </p:sldIdLst>
   <p:sldSz cx="12192000" cy="6858000"/>
   <p:notesSz cx="6858000" cy="9144000"/>
@@ -108,15 +112,258 @@
       </a:defRPr>
     </a:lvl9pPr>
   </p:defaultTextStyle>
+  <p:extLst>
+    <p:ext uri="{EFAFB233-063F-42B5-8137-9DF3F51BA10A}">
+      <p15:sldGuideLst xmlns:p15="http://schemas.microsoft.com/office/powerpoint/2012/main"/>
+    </p:ext>
+  </p:extLst>
 </p:presentation>
 </file>
 
 <file path=ppt/revisionInfo.xml><?xml version="1.0" encoding="utf-8"?>
 <p1510:revInfo xmlns:a="http://schemas.openxmlformats.org/drawingml/2006/main" xmlns:r="http://schemas.openxmlformats.org/officeDocument/2006/relationships" xmlns:p1510="http://schemas.microsoft.com/office/powerpoint/2015/10/main">
   <p1510:revLst>
-    <p1510:client id="{C8D9C79E-3820-3349-894B-A24D7E62B8F2}" v="11" dt="2026-07-23T14:05:58.344"/>
+    <p1510:client id="{C8D9C79E-3820-3349-894B-A24D7E62B8F2}" v="21" dt="2026-07-23T16:11:04.957"/>
   </p1510:revLst>
 </p1510:revInfo>
+</file>
+
+<file path=ppt/changesInfos/changesInfo1.xml><?xml version="1.0" encoding="utf-8"?>
+<pc:chgInfo xmlns:a="http://schemas.openxmlformats.org/drawingml/2006/main" xmlns:r="http://schemas.openxmlformats.org/officeDocument/2006/relationships" xmlns:ac="http://schemas.microsoft.com/office/drawing/2013/main/command" xmlns:pc="http://schemas.microsoft.com/office/powerpoint/2013/main/command">
+  <pc:docChgLst>
+    <pc:chgData name="Lars Pettersson" userId="bbe8ee3e1743ce4e" providerId="LiveId" clId="{76C9B083-C5CE-54A4-81E8-16672380D724}"/>
+    <pc:docChg chg="custSel addSld delSld modSld sldOrd">
+      <pc:chgData name="Lars Pettersson" userId="bbe8ee3e1743ce4e" providerId="LiveId" clId="{76C9B083-C5CE-54A4-81E8-16672380D724}" dt="2026-07-23T16:11:31.782" v="358" actId="1076"/>
+      <pc:docMkLst>
+        <pc:docMk/>
+      </pc:docMkLst>
+      <pc:sldChg chg="addSp modSp del">
+        <pc:chgData name="Lars Pettersson" userId="bbe8ee3e1743ce4e" providerId="LiveId" clId="{76C9B083-C5CE-54A4-81E8-16672380D724}" dt="2026-07-23T14:54:22.561" v="11" actId="2696"/>
+        <pc:sldMkLst>
+          <pc:docMk/>
+          <pc:sldMk cId="324411501" sldId="260"/>
+        </pc:sldMkLst>
+        <pc:picChg chg="add mod">
+          <ac:chgData name="Lars Pettersson" userId="bbe8ee3e1743ce4e" providerId="LiveId" clId="{76C9B083-C5CE-54A4-81E8-16672380D724}" dt="2026-07-23T14:23:08.409" v="0"/>
+          <ac:picMkLst>
+            <pc:docMk/>
+            <pc:sldMk cId="324411501" sldId="260"/>
+            <ac:picMk id="2" creationId="{F4C02CD4-7138-AC59-387E-18D0536210DF}"/>
+          </ac:picMkLst>
+        </pc:picChg>
+      </pc:sldChg>
+      <pc:sldChg chg="addSp delSp modSp new mod ord">
+        <pc:chgData name="Lars Pettersson" userId="bbe8ee3e1743ce4e" providerId="LiveId" clId="{76C9B083-C5CE-54A4-81E8-16672380D724}" dt="2026-07-23T14:54:28.082" v="12" actId="20578"/>
+        <pc:sldMkLst>
+          <pc:docMk/>
+          <pc:sldMk cId="84756324" sldId="261"/>
+        </pc:sldMkLst>
+        <pc:spChg chg="del">
+          <ac:chgData name="Lars Pettersson" userId="bbe8ee3e1743ce4e" providerId="LiveId" clId="{76C9B083-C5CE-54A4-81E8-16672380D724}" dt="2026-07-23T14:23:13.050" v="2" actId="478"/>
+          <ac:spMkLst>
+            <pc:docMk/>
+            <pc:sldMk cId="84756324" sldId="261"/>
+            <ac:spMk id="2" creationId="{876B3687-BC3B-F1BD-258C-90E6CD9EB6D8}"/>
+          </ac:spMkLst>
+        </pc:spChg>
+        <pc:spChg chg="del">
+          <ac:chgData name="Lars Pettersson" userId="bbe8ee3e1743ce4e" providerId="LiveId" clId="{76C9B083-C5CE-54A4-81E8-16672380D724}" dt="2026-07-23T14:23:13.050" v="2" actId="478"/>
+          <ac:spMkLst>
+            <pc:docMk/>
+            <pc:sldMk cId="84756324" sldId="261"/>
+            <ac:spMk id="3" creationId="{C1960BF0-F363-CF7F-AA48-AE61DFAF6863}"/>
+          </ac:spMkLst>
+        </pc:spChg>
+        <pc:picChg chg="add mod">
+          <ac:chgData name="Lars Pettersson" userId="bbe8ee3e1743ce4e" providerId="LiveId" clId="{76C9B083-C5CE-54A4-81E8-16672380D724}" dt="2026-07-23T14:39:55.285" v="3"/>
+          <ac:picMkLst>
+            <pc:docMk/>
+            <pc:sldMk cId="84756324" sldId="261"/>
+            <ac:picMk id="4" creationId="{8F1B3189-01D2-6941-D2DB-E06BC55D19F0}"/>
+          </ac:picMkLst>
+        </pc:picChg>
+      </pc:sldChg>
+      <pc:sldChg chg="addSp delSp modSp new mod">
+        <pc:chgData name="Lars Pettersson" userId="bbe8ee3e1743ce4e" providerId="LiveId" clId="{76C9B083-C5CE-54A4-81E8-16672380D724}" dt="2026-07-23T14:55:56.964" v="241" actId="1076"/>
+        <pc:sldMkLst>
+          <pc:docMk/>
+          <pc:sldMk cId="2756843972" sldId="262"/>
+        </pc:sldMkLst>
+        <pc:spChg chg="del">
+          <ac:chgData name="Lars Pettersson" userId="bbe8ee3e1743ce4e" providerId="LiveId" clId="{76C9B083-C5CE-54A4-81E8-16672380D724}" dt="2026-07-23T14:54:12.382" v="7" actId="478"/>
+          <ac:spMkLst>
+            <pc:docMk/>
+            <pc:sldMk cId="2756843972" sldId="262"/>
+            <ac:spMk id="2" creationId="{44A6F5DF-0A9A-3E20-5514-A388AF8CFDB9}"/>
+          </ac:spMkLst>
+        </pc:spChg>
+        <pc:spChg chg="del">
+          <ac:chgData name="Lars Pettersson" userId="bbe8ee3e1743ce4e" providerId="LiveId" clId="{76C9B083-C5CE-54A4-81E8-16672380D724}" dt="2026-07-23T14:54:12.382" v="7" actId="478"/>
+          <ac:spMkLst>
+            <pc:docMk/>
+            <pc:sldMk cId="2756843972" sldId="262"/>
+            <ac:spMk id="3" creationId="{96FC9671-02CB-ED78-A033-9C7481683FA2}"/>
+          </ac:spMkLst>
+        </pc:spChg>
+        <pc:spChg chg="add mod">
+          <ac:chgData name="Lars Pettersson" userId="bbe8ee3e1743ce4e" providerId="LiveId" clId="{76C9B083-C5CE-54A4-81E8-16672380D724}" dt="2026-07-23T14:55:56.964" v="241" actId="1076"/>
+          <ac:spMkLst>
+            <pc:docMk/>
+            <pc:sldMk cId="2756843972" sldId="262"/>
+            <ac:spMk id="5" creationId="{D4427748-0B83-770A-3A20-1B461EBE8E33}"/>
+          </ac:spMkLst>
+        </pc:spChg>
+        <pc:spChg chg="add mod">
+          <ac:chgData name="Lars Pettersson" userId="bbe8ee3e1743ce4e" providerId="LiveId" clId="{76C9B083-C5CE-54A4-81E8-16672380D724}" dt="2026-07-23T14:55:52.231" v="240" actId="14100"/>
+          <ac:spMkLst>
+            <pc:docMk/>
+            <pc:sldMk cId="2756843972" sldId="262"/>
+            <ac:spMk id="6" creationId="{BFD88252-D2FB-B8EA-C696-4D042C70509D}"/>
+          </ac:spMkLst>
+        </pc:spChg>
+      </pc:sldChg>
+      <pc:sldChg chg="addSp delSp new mod">
+        <pc:chgData name="Lars Pettersson" userId="bbe8ee3e1743ce4e" providerId="LiveId" clId="{76C9B083-C5CE-54A4-81E8-16672380D724}" dt="2026-07-23T14:59:50.045" v="246"/>
+        <pc:sldMkLst>
+          <pc:docMk/>
+          <pc:sldMk cId="728802897" sldId="263"/>
+        </pc:sldMkLst>
+        <pc:spChg chg="del">
+          <ac:chgData name="Lars Pettersson" userId="bbe8ee3e1743ce4e" providerId="LiveId" clId="{76C9B083-C5CE-54A4-81E8-16672380D724}" dt="2026-07-23T14:59:37.958" v="243" actId="478"/>
+          <ac:spMkLst>
+            <pc:docMk/>
+            <pc:sldMk cId="728802897" sldId="263"/>
+            <ac:spMk id="2" creationId="{B747E214-9A03-2186-8EA8-097A3C8DB320}"/>
+          </ac:spMkLst>
+        </pc:spChg>
+        <pc:spChg chg="del">
+          <ac:chgData name="Lars Pettersson" userId="bbe8ee3e1743ce4e" providerId="LiveId" clId="{76C9B083-C5CE-54A4-81E8-16672380D724}" dt="2026-07-23T14:59:37.958" v="243" actId="478"/>
+          <ac:spMkLst>
+            <pc:docMk/>
+            <pc:sldMk cId="728802897" sldId="263"/>
+            <ac:spMk id="3" creationId="{6ED04CA5-C966-18A2-BD66-60465867405F}"/>
+          </ac:spMkLst>
+        </pc:spChg>
+        <pc:picChg chg="add del">
+          <ac:chgData name="Lars Pettersson" userId="bbe8ee3e1743ce4e" providerId="LiveId" clId="{76C9B083-C5CE-54A4-81E8-16672380D724}" dt="2026-07-23T14:59:44.681" v="245" actId="478"/>
+          <ac:picMkLst>
+            <pc:docMk/>
+            <pc:sldMk cId="728802897" sldId="263"/>
+            <ac:picMk id="4" creationId="{536B4F7C-D9D0-F65B-0B2F-46DCFFB32BDA}"/>
+          </ac:picMkLst>
+        </pc:picChg>
+        <pc:picChg chg="add">
+          <ac:chgData name="Lars Pettersson" userId="bbe8ee3e1743ce4e" providerId="LiveId" clId="{76C9B083-C5CE-54A4-81E8-16672380D724}" dt="2026-07-23T14:59:50.045" v="246"/>
+          <ac:picMkLst>
+            <pc:docMk/>
+            <pc:sldMk cId="728802897" sldId="263"/>
+            <ac:picMk id="5" creationId="{804170A8-4F2F-C242-040D-8FE7ED082F8B}"/>
+          </ac:picMkLst>
+        </pc:picChg>
+      </pc:sldChg>
+      <pc:sldChg chg="new del">
+        <pc:chgData name="Lars Pettersson" userId="bbe8ee3e1743ce4e" providerId="LiveId" clId="{76C9B083-C5CE-54A4-81E8-16672380D724}" dt="2026-07-23T14:54:16.104" v="9" actId="2696"/>
+        <pc:sldMkLst>
+          <pc:docMk/>
+          <pc:sldMk cId="3294062036" sldId="263"/>
+        </pc:sldMkLst>
+      </pc:sldChg>
+      <pc:sldChg chg="addSp delSp modSp new mod">
+        <pc:chgData name="Lars Pettersson" userId="bbe8ee3e1743ce4e" providerId="LiveId" clId="{76C9B083-C5CE-54A4-81E8-16672380D724}" dt="2026-07-23T15:01:41.595" v="306" actId="20577"/>
+        <pc:sldMkLst>
+          <pc:docMk/>
+          <pc:sldMk cId="501532766" sldId="264"/>
+        </pc:sldMkLst>
+        <pc:spChg chg="del">
+          <ac:chgData name="Lars Pettersson" userId="bbe8ee3e1743ce4e" providerId="LiveId" clId="{76C9B083-C5CE-54A4-81E8-16672380D724}" dt="2026-07-23T14:59:54.920" v="248" actId="478"/>
+          <ac:spMkLst>
+            <pc:docMk/>
+            <pc:sldMk cId="501532766" sldId="264"/>
+            <ac:spMk id="2" creationId="{99F5DF59-8E68-0711-F186-17164273B327}"/>
+          </ac:spMkLst>
+        </pc:spChg>
+        <pc:spChg chg="del">
+          <ac:chgData name="Lars Pettersson" userId="bbe8ee3e1743ce4e" providerId="LiveId" clId="{76C9B083-C5CE-54A4-81E8-16672380D724}" dt="2026-07-23T14:59:54.920" v="248" actId="478"/>
+          <ac:spMkLst>
+            <pc:docMk/>
+            <pc:sldMk cId="501532766" sldId="264"/>
+            <ac:spMk id="3" creationId="{6C423882-9544-13FC-9F4F-E9F83B0090C5}"/>
+          </ac:spMkLst>
+        </pc:spChg>
+        <pc:spChg chg="add mod">
+          <ac:chgData name="Lars Pettersson" userId="bbe8ee3e1743ce4e" providerId="LiveId" clId="{76C9B083-C5CE-54A4-81E8-16672380D724}" dt="2026-07-23T15:01:06.435" v="252" actId="20577"/>
+          <ac:spMkLst>
+            <pc:docMk/>
+            <pc:sldMk cId="501532766" sldId="264"/>
+            <ac:spMk id="6" creationId="{4B8DB9FC-8FDA-D8D5-EDDF-B4EECD2FCFAC}"/>
+          </ac:spMkLst>
+        </pc:spChg>
+        <pc:spChg chg="add mod">
+          <ac:chgData name="Lars Pettersson" userId="bbe8ee3e1743ce4e" providerId="LiveId" clId="{76C9B083-C5CE-54A4-81E8-16672380D724}" dt="2026-07-23T15:01:41.595" v="306" actId="20577"/>
+          <ac:spMkLst>
+            <pc:docMk/>
+            <pc:sldMk cId="501532766" sldId="264"/>
+            <ac:spMk id="7" creationId="{11C20EE1-12C8-AE8A-CF9F-D8F8698C9CB9}"/>
+          </ac:spMkLst>
+        </pc:spChg>
+        <pc:picChg chg="add mod">
+          <ac:chgData name="Lars Pettersson" userId="bbe8ee3e1743ce4e" providerId="LiveId" clId="{76C9B083-C5CE-54A4-81E8-16672380D724}" dt="2026-07-23T15:00:38.946" v="249"/>
+          <ac:picMkLst>
+            <pc:docMk/>
+            <pc:sldMk cId="501532766" sldId="264"/>
+            <ac:picMk id="4" creationId="{0004F936-23B5-F31B-7181-23A36CCD16B7}"/>
+          </ac:picMkLst>
+        </pc:picChg>
+      </pc:sldChg>
+      <pc:sldChg chg="new del">
+        <pc:chgData name="Lars Pettersson" userId="bbe8ee3e1743ce4e" providerId="LiveId" clId="{76C9B083-C5CE-54A4-81E8-16672380D724}" dt="2026-07-23T14:54:16.758" v="10" actId="2696"/>
+        <pc:sldMkLst>
+          <pc:docMk/>
+          <pc:sldMk cId="4056060313" sldId="264"/>
+        </pc:sldMkLst>
+      </pc:sldChg>
+      <pc:sldChg chg="addSp delSp modSp new mod">
+        <pc:chgData name="Lars Pettersson" userId="bbe8ee3e1743ce4e" providerId="LiveId" clId="{76C9B083-C5CE-54A4-81E8-16672380D724}" dt="2026-07-23T16:11:31.782" v="358" actId="1076"/>
+        <pc:sldMkLst>
+          <pc:docMk/>
+          <pc:sldMk cId="4207058427" sldId="265"/>
+        </pc:sldMkLst>
+        <pc:spChg chg="mod">
+          <ac:chgData name="Lars Pettersson" userId="bbe8ee3e1743ce4e" providerId="LiveId" clId="{76C9B083-C5CE-54A4-81E8-16672380D724}" dt="2026-07-23T15:03:59.428" v="349" actId="20577"/>
+          <ac:spMkLst>
+            <pc:docMk/>
+            <pc:sldMk cId="4207058427" sldId="265"/>
+            <ac:spMk id="2" creationId="{33FABF8A-9DB4-7AF8-27A9-F8D57ECB703B}"/>
+          </ac:spMkLst>
+        </pc:spChg>
+        <pc:spChg chg="del">
+          <ac:chgData name="Lars Pettersson" userId="bbe8ee3e1743ce4e" providerId="LiveId" clId="{76C9B083-C5CE-54A4-81E8-16672380D724}" dt="2026-07-23T15:04:01.780" v="350"/>
+          <ac:spMkLst>
+            <pc:docMk/>
+            <pc:sldMk cId="4207058427" sldId="265"/>
+            <ac:spMk id="3" creationId="{D9C7D27F-5E91-96B9-DF4A-0E6BC3853F35}"/>
+          </ac:spMkLst>
+        </pc:spChg>
+        <pc:picChg chg="add mod">
+          <ac:chgData name="Lars Pettersson" userId="bbe8ee3e1743ce4e" providerId="LiveId" clId="{76C9B083-C5CE-54A4-81E8-16672380D724}" dt="2026-07-23T16:11:02.465" v="352" actId="14100"/>
+          <ac:picMkLst>
+            <pc:docMk/>
+            <pc:sldMk cId="4207058427" sldId="265"/>
+            <ac:picMk id="4" creationId="{F7E7F6F2-0880-0EFE-E81B-57DC12A85629}"/>
+          </ac:picMkLst>
+        </pc:picChg>
+        <pc:picChg chg="add mod">
+          <ac:chgData name="Lars Pettersson" userId="bbe8ee3e1743ce4e" providerId="LiveId" clId="{76C9B083-C5CE-54A4-81E8-16672380D724}" dt="2026-07-23T16:11:31.782" v="358" actId="1076"/>
+          <ac:picMkLst>
+            <pc:docMk/>
+            <pc:sldMk cId="4207058427" sldId="265"/>
+            <ac:picMk id="5" creationId="{FC50B3F3-E9C6-0FC6-6C93-D9C1B6C3A0A3}"/>
+          </ac:picMkLst>
+        </pc:picChg>
+      </pc:sldChg>
+    </pc:docChg>
+  </pc:docChgLst>
+</pc:chgInfo>
 </file>
 
 <file path=ppt/slideLayouts/slideLayout1.xml><?xml version="1.0" encoding="utf-8"?>
@@ -3693,10 +3940,723 @@
           <a:chExt cx="0" cy="0"/>
         </a:xfrm>
       </p:grpSpPr>
+      <p:pic>
+        <p:nvPicPr>
+          <p:cNvPr id="4" name="Picture 3">
+            <a:extLst>
+              <a:ext uri="{FF2B5EF4-FFF2-40B4-BE49-F238E27FC236}">
+                <a16:creationId xmlns:a16="http://schemas.microsoft.com/office/drawing/2014/main" id="{8F1B3189-01D2-6941-D2DB-E06BC55D19F0}"/>
+              </a:ext>
+            </a:extLst>
+          </p:cNvPr>
+          <p:cNvPicPr>
+            <a:picLocks noChangeAspect="1"/>
+          </p:cNvPicPr>
+          <p:nvPr/>
+        </p:nvPicPr>
+        <p:blipFill>
+          <a:blip r:embed="rId2"/>
+          <a:stretch>
+            <a:fillRect/>
+          </a:stretch>
+        </p:blipFill>
+        <p:spPr>
+          <a:xfrm>
+            <a:off x="2209800" y="1586705"/>
+            <a:ext cx="7772400" cy="3684590"/>
+          </a:xfrm>
+          <a:prstGeom prst="rect">
+            <a:avLst/>
+          </a:prstGeom>
+        </p:spPr>
+      </p:pic>
     </p:spTree>
     <p:extLst>
       <p:ext uri="{BB962C8B-B14F-4D97-AF65-F5344CB8AC3E}">
-        <p14:creationId xmlns:p14="http://schemas.microsoft.com/office/powerpoint/2010/main" val="324411501"/>
+        <p14:creationId xmlns:p14="http://schemas.microsoft.com/office/powerpoint/2010/main" val="84756324"/>
+      </p:ext>
+    </p:extLst>
+  </p:cSld>
+  <p:clrMapOvr>
+    <a:masterClrMapping/>
+  </p:clrMapOvr>
+</p:sld>
+</file>
+
+<file path=ppt/slides/slide6.xml><?xml version="1.0" encoding="utf-8"?>
+<p:sld xmlns:a="http://schemas.openxmlformats.org/drawingml/2006/main" xmlns:r="http://schemas.openxmlformats.org/officeDocument/2006/relationships" xmlns:p="http://schemas.openxmlformats.org/presentationml/2006/main">
+  <p:cSld>
+    <p:spTree>
+      <p:nvGrpSpPr>
+        <p:cNvPr id="1" name=""/>
+        <p:cNvGrpSpPr/>
+        <p:nvPr/>
+      </p:nvGrpSpPr>
+      <p:grpSpPr>
+        <a:xfrm>
+          <a:off x="0" y="0"/>
+          <a:ext cx="0" cy="0"/>
+          <a:chOff x="0" y="0"/>
+          <a:chExt cx="0" cy="0"/>
+        </a:xfrm>
+      </p:grpSpPr>
+      <p:sp>
+        <p:nvSpPr>
+          <p:cNvPr id="5" name="TextBox 4">
+            <a:extLst>
+              <a:ext uri="{FF2B5EF4-FFF2-40B4-BE49-F238E27FC236}">
+                <a16:creationId xmlns:a16="http://schemas.microsoft.com/office/drawing/2014/main" id="{D4427748-0B83-770A-3A20-1B461EBE8E33}"/>
+              </a:ext>
+            </a:extLst>
+          </p:cNvPr>
+          <p:cNvSpPr txBox="1"/>
+          <p:nvPr/>
+        </p:nvSpPr>
+        <p:spPr>
+          <a:xfrm>
+            <a:off x="3046971" y="1738263"/>
+            <a:ext cx="6098058" cy="4524315"/>
+          </a:xfrm>
+          <a:prstGeom prst="rect">
+            <a:avLst/>
+          </a:prstGeom>
+          <a:noFill/>
+        </p:spPr>
+        <p:txBody>
+          <a:bodyPr wrap="square">
+            <a:spAutoFit/>
+          </a:bodyPr>
+          <a:lstStyle/>
+          <a:p>
+            <a:pPr>
+              <a:buNone/>
+            </a:pPr>
+            <a:r>
+              <a:rPr lang="en-US" b="1" dirty="0"/>
+              <a:t>Manual steps (recommended if you want it in the HTA </a:t>
+            </a:r>
+            <a:r>
+              <a:rPr lang="en-US" b="1" dirty="0" err="1"/>
+              <a:t>Penpot</a:t>
+            </a:r>
+            <a:r>
+              <a:rPr lang="en-US" b="1" dirty="0"/>
+              <a:t> file)</a:t>
+            </a:r>
+          </a:p>
+          <a:p>
+            <a:pPr marL="342900" lvl="0" indent="-342900">
+              <a:buFont typeface="+mj-lt"/>
+              <a:buAutoNum type="arabicPeriod"/>
+            </a:pPr>
+            <a:r>
+              <a:rPr lang="en-US" dirty="0"/>
+              <a:t>In </a:t>
+            </a:r>
+            <a:r>
+              <a:rPr lang="en-US" dirty="0" err="1"/>
+              <a:t>Penpot</a:t>
+            </a:r>
+            <a:r>
+              <a:rPr lang="en-US" dirty="0"/>
+              <a:t>, open </a:t>
+            </a:r>
+            <a:r>
+              <a:rPr lang="en-US" b="1" dirty="0"/>
+              <a:t>HFA DS</a:t>
+            </a:r>
+            <a:r>
+              <a:rPr lang="en-US" dirty="0"/>
+              <a:t> → page </a:t>
+            </a:r>
+            <a:r>
+              <a:rPr lang="en-US" b="1" dirty="0"/>
+              <a:t>TTA draft</a:t>
+            </a:r>
+            <a:r>
+              <a:rPr lang="en-US" dirty="0"/>
+              <a:t>.</a:t>
+            </a:r>
+          </a:p>
+          <a:p>
+            <a:pPr marL="342900" lvl="0" indent="-342900">
+              <a:buFont typeface="+mj-lt"/>
+              <a:buAutoNum type="arabicPeriod"/>
+            </a:pPr>
+            <a:r>
+              <a:rPr lang="en-US" dirty="0"/>
+              <a:t>Select the Example board/frame (the HTA + TTA sync composition in your screenshot).</a:t>
+            </a:r>
+          </a:p>
+          <a:p>
+            <a:pPr marL="342900" lvl="0" indent="-342900">
+              <a:buFont typeface="+mj-lt"/>
+              <a:buAutoNum type="arabicPeriod"/>
+            </a:pPr>
+            <a:r>
+              <a:rPr lang="en-US" dirty="0"/>
+              <a:t>Copy (</a:t>
+            </a:r>
+            <a:r>
+              <a:rPr lang="en-US" dirty="0" err="1">
+                <a:latin typeface="Courier New" panose="02070309020205020404" pitchFamily="49" charset="0"/>
+              </a:rPr>
+              <a:t>Cmd</a:t>
+            </a:r>
+            <a:r>
+              <a:rPr lang="en-US" dirty="0">
+                <a:latin typeface="Courier New" panose="02070309020205020404" pitchFamily="49" charset="0"/>
+              </a:rPr>
+              <a:t>/</a:t>
+            </a:r>
+            <a:r>
+              <a:rPr lang="en-US" dirty="0" err="1">
+                <a:latin typeface="Courier New" panose="02070309020205020404" pitchFamily="49" charset="0"/>
+              </a:rPr>
+              <a:t>Ctrl+C</a:t>
+            </a:r>
+            <a:r>
+              <a:rPr lang="en-US" dirty="0"/>
+              <a:t>).</a:t>
+            </a:r>
+          </a:p>
+          <a:p>
+            <a:pPr marL="342900" lvl="0" indent="-342900">
+              <a:buFont typeface="+mj-lt"/>
+              <a:buAutoNum type="arabicPeriod"/>
+            </a:pPr>
+            <a:r>
+              <a:rPr lang="en-US" dirty="0"/>
+              <a:t>Open the </a:t>
+            </a:r>
+            <a:r>
+              <a:rPr lang="en-US" b="1" dirty="0"/>
+              <a:t>HTA</a:t>
+            </a:r>
+            <a:r>
+              <a:rPr lang="en-US" dirty="0"/>
+              <a:t> </a:t>
+            </a:r>
+            <a:r>
+              <a:rPr lang="en-US" dirty="0" err="1"/>
+              <a:t>Penpot</a:t>
+            </a:r>
+            <a:r>
+              <a:rPr lang="en-US" dirty="0"/>
+              <a:t> file (import </a:t>
+            </a:r>
+            <a:r>
+              <a:rPr lang="en-US" dirty="0">
+                <a:latin typeface="Courier New" panose="02070309020205020404" pitchFamily="49" charset="0"/>
+              </a:rPr>
+              <a:t>[</a:t>
+            </a:r>
+            <a:r>
+              <a:rPr lang="en-US" dirty="0" err="1">
+                <a:latin typeface="Courier New" panose="02070309020205020404" pitchFamily="49" charset="0"/>
+              </a:rPr>
+              <a:t>HTA.penpot</a:t>
+            </a:r>
+            <a:r>
+              <a:rPr lang="en-US" dirty="0">
+                <a:latin typeface="Courier New" panose="02070309020205020404" pitchFamily="49" charset="0"/>
+              </a:rPr>
+              <a:t>](HTA-tool/</a:t>
+            </a:r>
+            <a:r>
+              <a:rPr lang="en-US" dirty="0" err="1">
+                <a:latin typeface="Courier New" panose="02070309020205020404" pitchFamily="49" charset="0"/>
+              </a:rPr>
+              <a:t>HTA.penpot</a:t>
+            </a:r>
+            <a:r>
+              <a:rPr lang="en-US" dirty="0">
+                <a:latin typeface="Courier New" panose="02070309020205020404" pitchFamily="49" charset="0"/>
+              </a:rPr>
+              <a:t>)</a:t>
+            </a:r>
+            <a:r>
+              <a:rPr lang="en-US" dirty="0"/>
+              <a:t> into </a:t>
+            </a:r>
+            <a:r>
+              <a:rPr lang="en-US" dirty="0" err="1"/>
+              <a:t>Penpot</a:t>
+            </a:r>
+            <a:r>
+              <a:rPr lang="en-US" dirty="0"/>
+              <a:t> if it only exists on disk).</a:t>
+            </a:r>
+          </a:p>
+          <a:p>
+            <a:pPr marL="342900" lvl="0" indent="-342900">
+              <a:buFont typeface="+mj-lt"/>
+              <a:buAutoNum type="arabicPeriod"/>
+            </a:pPr>
+            <a:r>
+              <a:rPr lang="en-US" dirty="0"/>
+              <a:t>Paste (</a:t>
+            </a:r>
+            <a:r>
+              <a:rPr lang="en-US" dirty="0" err="1">
+                <a:latin typeface="Courier New" panose="02070309020205020404" pitchFamily="49" charset="0"/>
+              </a:rPr>
+              <a:t>Cmd</a:t>
+            </a:r>
+            <a:r>
+              <a:rPr lang="en-US" dirty="0">
+                <a:latin typeface="Courier New" panose="02070309020205020404" pitchFamily="49" charset="0"/>
+              </a:rPr>
+              <a:t>/</a:t>
+            </a:r>
+            <a:r>
+              <a:rPr lang="en-US" dirty="0" err="1">
+                <a:latin typeface="Courier New" panose="02070309020205020404" pitchFamily="49" charset="0"/>
+              </a:rPr>
+              <a:t>Ctrl+V</a:t>
+            </a:r>
+            <a:r>
+              <a:rPr lang="en-US" dirty="0"/>
+              <a:t>) onto a page (create e.g. </a:t>
+            </a:r>
+            <a:r>
+              <a:rPr lang="en-US" dirty="0">
+                <a:latin typeface="Courier New" panose="02070309020205020404" pitchFamily="49" charset="0"/>
+              </a:rPr>
+              <a:t>TTA draft</a:t>
+            </a:r>
+            <a:r>
+              <a:rPr lang="en-US" dirty="0"/>
+              <a:t> if missing).</a:t>
+            </a:r>
+          </a:p>
+          <a:p>
+            <a:pPr marL="342900" lvl="0" indent="-342900">
+              <a:buFont typeface="+mj-lt"/>
+              <a:buAutoNum type="arabicPeriod"/>
+            </a:pPr>
+            <a:r>
+              <a:rPr lang="en-US" dirty="0"/>
+              <a:t>If components look broken: </a:t>
+            </a:r>
+            <a:r>
+              <a:rPr lang="en-US" b="1" dirty="0"/>
+              <a:t>Assets → connect library → HFA DS</a:t>
+            </a:r>
+            <a:r>
+              <a:rPr lang="en-US" dirty="0"/>
+              <a:t> (or copy needed local components into the HTA file).</a:t>
+            </a:r>
+          </a:p>
+          <a:p>
+            <a:pPr marL="342900" lvl="0" indent="-342900">
+              <a:buFont typeface="+mj-lt"/>
+              <a:buAutoNum type="arabicPeriod"/>
+            </a:pPr>
+            <a:r>
+              <a:rPr lang="en-US" dirty="0"/>
+              <a:t>Optionally reconnect the MCP plugin to the HTA file so later MCP edits target that file.</a:t>
+            </a:r>
+          </a:p>
+        </p:txBody>
+      </p:sp>
+      <p:sp>
+        <p:nvSpPr>
+          <p:cNvPr id="6" name="TextBox 5">
+            <a:extLst>
+              <a:ext uri="{FF2B5EF4-FFF2-40B4-BE49-F238E27FC236}">
+                <a16:creationId xmlns:a16="http://schemas.microsoft.com/office/drawing/2014/main" id="{BFD88252-D2FB-B8EA-C696-4D042C70509D}"/>
+              </a:ext>
+            </a:extLst>
+          </p:cNvPr>
+          <p:cNvSpPr txBox="1"/>
+          <p:nvPr/>
+        </p:nvSpPr>
+        <p:spPr>
+          <a:xfrm>
+            <a:off x="861237" y="595422"/>
+            <a:ext cx="9335386" cy="646331"/>
+          </a:xfrm>
+          <a:prstGeom prst="rect">
+            <a:avLst/>
+          </a:prstGeom>
+          <a:noFill/>
+        </p:spPr>
+        <p:txBody>
+          <a:bodyPr wrap="square" rtlCol="0">
+            <a:spAutoFit/>
+          </a:bodyPr>
+          <a:lstStyle/>
+          <a:p>
+            <a:r>
+              <a:rPr lang="en-US" dirty="0" err="1"/>
+              <a:t>Penpot</a:t>
+            </a:r>
+            <a:r>
+              <a:rPr lang="en-US" dirty="0"/>
+              <a:t> MCP only allows one file at the time. Therefore it is problematic to move examples outside of the design system </a:t>
+            </a:r>
+            <a:r>
+              <a:rPr lang="en-US" dirty="0" err="1"/>
+              <a:t>liknked</a:t>
+            </a:r>
+            <a:r>
+              <a:rPr lang="en-US" dirty="0"/>
+              <a:t> library</a:t>
+            </a:r>
+          </a:p>
+        </p:txBody>
+      </p:sp>
+    </p:spTree>
+    <p:extLst>
+      <p:ext uri="{BB962C8B-B14F-4D97-AF65-F5344CB8AC3E}">
+        <p14:creationId xmlns:p14="http://schemas.microsoft.com/office/powerpoint/2010/main" val="2756843972"/>
+      </p:ext>
+    </p:extLst>
+  </p:cSld>
+  <p:clrMapOvr>
+    <a:masterClrMapping/>
+  </p:clrMapOvr>
+</p:sld>
+</file>
+
+<file path=ppt/slides/slide7.xml><?xml version="1.0" encoding="utf-8"?>
+<p:sld xmlns:a="http://schemas.openxmlformats.org/drawingml/2006/main" xmlns:r="http://schemas.openxmlformats.org/officeDocument/2006/relationships" xmlns:p="http://schemas.openxmlformats.org/presentationml/2006/main">
+  <p:cSld>
+    <p:spTree>
+      <p:nvGrpSpPr>
+        <p:cNvPr id="1" name=""/>
+        <p:cNvGrpSpPr/>
+        <p:nvPr/>
+      </p:nvGrpSpPr>
+      <p:grpSpPr>
+        <a:xfrm>
+          <a:off x="0" y="0"/>
+          <a:ext cx="0" cy="0"/>
+          <a:chOff x="0" y="0"/>
+          <a:chExt cx="0" cy="0"/>
+        </a:xfrm>
+      </p:grpSpPr>
+      <p:pic>
+        <p:nvPicPr>
+          <p:cNvPr id="5" name="Picture 4">
+            <a:extLst>
+              <a:ext uri="{FF2B5EF4-FFF2-40B4-BE49-F238E27FC236}">
+                <a16:creationId xmlns:a16="http://schemas.microsoft.com/office/drawing/2014/main" id="{804170A8-4F2F-C242-040D-8FE7ED082F8B}"/>
+              </a:ext>
+            </a:extLst>
+          </p:cNvPr>
+          <p:cNvPicPr>
+            <a:picLocks noChangeAspect="1"/>
+          </p:cNvPicPr>
+          <p:nvPr/>
+        </p:nvPicPr>
+        <p:blipFill>
+          <a:blip r:embed="rId2"/>
+          <a:stretch>
+            <a:fillRect/>
+          </a:stretch>
+        </p:blipFill>
+        <p:spPr>
+          <a:xfrm>
+            <a:off x="2878376" y="0"/>
+            <a:ext cx="6435247" cy="6858000"/>
+          </a:xfrm>
+          <a:prstGeom prst="rect">
+            <a:avLst/>
+          </a:prstGeom>
+        </p:spPr>
+      </p:pic>
+    </p:spTree>
+    <p:extLst>
+      <p:ext uri="{BB962C8B-B14F-4D97-AF65-F5344CB8AC3E}">
+        <p14:creationId xmlns:p14="http://schemas.microsoft.com/office/powerpoint/2010/main" val="728802897"/>
+      </p:ext>
+    </p:extLst>
+  </p:cSld>
+  <p:clrMapOvr>
+    <a:masterClrMapping/>
+  </p:clrMapOvr>
+</p:sld>
+</file>
+
+<file path=ppt/slides/slide8.xml><?xml version="1.0" encoding="utf-8"?>
+<p:sld xmlns:a="http://schemas.openxmlformats.org/drawingml/2006/main" xmlns:r="http://schemas.openxmlformats.org/officeDocument/2006/relationships" xmlns:p="http://schemas.openxmlformats.org/presentationml/2006/main">
+  <p:cSld>
+    <p:spTree>
+      <p:nvGrpSpPr>
+        <p:cNvPr id="1" name=""/>
+        <p:cNvGrpSpPr/>
+        <p:nvPr/>
+      </p:nvGrpSpPr>
+      <p:grpSpPr>
+        <a:xfrm>
+          <a:off x="0" y="0"/>
+          <a:ext cx="0" cy="0"/>
+          <a:chOff x="0" y="0"/>
+          <a:chExt cx="0" cy="0"/>
+        </a:xfrm>
+      </p:grpSpPr>
+      <p:pic>
+        <p:nvPicPr>
+          <p:cNvPr id="4" name="Picture 3">
+            <a:extLst>
+              <a:ext uri="{FF2B5EF4-FFF2-40B4-BE49-F238E27FC236}">
+                <a16:creationId xmlns:a16="http://schemas.microsoft.com/office/drawing/2014/main" id="{0004F936-23B5-F31B-7181-23A36CCD16B7}"/>
+              </a:ext>
+            </a:extLst>
+          </p:cNvPr>
+          <p:cNvPicPr>
+            <a:picLocks noChangeAspect="1"/>
+          </p:cNvPicPr>
+          <p:nvPr/>
+        </p:nvPicPr>
+        <p:blipFill>
+          <a:blip r:embed="rId2"/>
+          <a:stretch>
+            <a:fillRect/>
+          </a:stretch>
+        </p:blipFill>
+        <p:spPr>
+          <a:xfrm>
+            <a:off x="2209800" y="897663"/>
+            <a:ext cx="7772400" cy="5062673"/>
+          </a:xfrm>
+          <a:prstGeom prst="rect">
+            <a:avLst/>
+          </a:prstGeom>
+        </p:spPr>
+      </p:pic>
+      <p:sp>
+        <p:nvSpPr>
+          <p:cNvPr id="6" name="TextBox 5">
+            <a:extLst>
+              <a:ext uri="{FF2B5EF4-FFF2-40B4-BE49-F238E27FC236}">
+                <a16:creationId xmlns:a16="http://schemas.microsoft.com/office/drawing/2014/main" id="{4B8DB9FC-8FDA-D8D5-EDDF-B4EECD2FCFAC}"/>
+              </a:ext>
+            </a:extLst>
+          </p:cNvPr>
+          <p:cNvSpPr txBox="1"/>
+          <p:nvPr/>
+        </p:nvSpPr>
+        <p:spPr>
+          <a:xfrm>
+            <a:off x="238923" y="356168"/>
+            <a:ext cx="6098058" cy="369332"/>
+          </a:xfrm>
+          <a:prstGeom prst="rect">
+            <a:avLst/>
+          </a:prstGeom>
+          <a:noFill/>
+        </p:spPr>
+        <p:txBody>
+          <a:bodyPr wrap="square">
+            <a:spAutoFit/>
+          </a:bodyPr>
+          <a:lstStyle/>
+          <a:p>
+            <a:r>
+              <a:rPr lang="en-US" dirty="0">
+                <a:hlinkClick r:id="rId3"/>
+              </a:rPr>
+              <a:t>https://share.gemini.google/eP3YJwEQcFl4</a:t>
+            </a:r>
+            <a:r>
+              <a:rPr lang="en-US" dirty="0"/>
+              <a:t> </a:t>
+            </a:r>
+          </a:p>
+        </p:txBody>
+      </p:sp>
+      <p:sp>
+        <p:nvSpPr>
+          <p:cNvPr id="7" name="TextBox 6">
+            <a:extLst>
+              <a:ext uri="{FF2B5EF4-FFF2-40B4-BE49-F238E27FC236}">
+                <a16:creationId xmlns:a16="http://schemas.microsoft.com/office/drawing/2014/main" id="{11C20EE1-12C8-AE8A-CF9F-D8F8698C9CB9}"/>
+              </a:ext>
+            </a:extLst>
+          </p:cNvPr>
+          <p:cNvSpPr txBox="1"/>
+          <p:nvPr/>
+        </p:nvSpPr>
+        <p:spPr>
+          <a:xfrm>
+            <a:off x="6226139" y="356168"/>
+            <a:ext cx="4114460" cy="369332"/>
+          </a:xfrm>
+          <a:prstGeom prst="rect">
+            <a:avLst/>
+          </a:prstGeom>
+          <a:noFill/>
+        </p:spPr>
+        <p:txBody>
+          <a:bodyPr wrap="none" rtlCol="0">
+            <a:spAutoFit/>
+          </a:bodyPr>
+          <a:lstStyle/>
+          <a:p>
+            <a:r>
+              <a:rPr lang="en-US" dirty="0"/>
+              <a:t>Gemini generated example for HFA HTA </a:t>
+            </a:r>
+          </a:p>
+        </p:txBody>
+      </p:sp>
+    </p:spTree>
+    <p:extLst>
+      <p:ext uri="{BB962C8B-B14F-4D97-AF65-F5344CB8AC3E}">
+        <p14:creationId xmlns:p14="http://schemas.microsoft.com/office/powerpoint/2010/main" val="501532766"/>
+      </p:ext>
+    </p:extLst>
+  </p:cSld>
+  <p:clrMapOvr>
+    <a:masterClrMapping/>
+  </p:clrMapOvr>
+</p:sld>
+</file>
+
+<file path=ppt/slides/slide9.xml><?xml version="1.0" encoding="utf-8"?>
+<p:sld xmlns:a="http://schemas.openxmlformats.org/drawingml/2006/main" xmlns:r="http://schemas.openxmlformats.org/officeDocument/2006/relationships" xmlns:p="http://schemas.openxmlformats.org/presentationml/2006/main">
+  <p:cSld>
+    <p:spTree>
+      <p:nvGrpSpPr>
+        <p:cNvPr id="1" name=""/>
+        <p:cNvGrpSpPr/>
+        <p:nvPr/>
+      </p:nvGrpSpPr>
+      <p:grpSpPr>
+        <a:xfrm>
+          <a:off x="0" y="0"/>
+          <a:ext cx="0" cy="0"/>
+          <a:chOff x="0" y="0"/>
+          <a:chExt cx="0" cy="0"/>
+        </a:xfrm>
+      </p:grpSpPr>
+      <p:sp>
+        <p:nvSpPr>
+          <p:cNvPr id="2" name="Title 1">
+            <a:extLst>
+              <a:ext uri="{FF2B5EF4-FFF2-40B4-BE49-F238E27FC236}">
+                <a16:creationId xmlns:a16="http://schemas.microsoft.com/office/drawing/2014/main" id="{33FABF8A-9DB4-7AF8-27A9-F8D57ECB703B}"/>
+              </a:ext>
+            </a:extLst>
+          </p:cNvPr>
+          <p:cNvSpPr>
+            <a:spLocks noGrp="1"/>
+          </p:cNvSpPr>
+          <p:nvPr>
+            <p:ph type="title"/>
+          </p:nvPr>
+        </p:nvSpPr>
+        <p:spPr/>
+        <p:txBody>
+          <a:bodyPr/>
+          <a:lstStyle/>
+          <a:p>
+            <a:r>
+              <a:rPr lang="en-US" dirty="0"/>
+              <a:t>Manage changes in JSON structure</a:t>
+            </a:r>
+          </a:p>
+        </p:txBody>
+      </p:sp>
+      <p:pic>
+        <p:nvPicPr>
+          <p:cNvPr id="4" name="Content Placeholder 3">
+            <a:extLst>
+              <a:ext uri="{FF2B5EF4-FFF2-40B4-BE49-F238E27FC236}">
+                <a16:creationId xmlns:a16="http://schemas.microsoft.com/office/drawing/2014/main" id="{F7E7F6F2-0880-0EFE-E81B-57DC12A85629}"/>
+              </a:ext>
+            </a:extLst>
+          </p:cNvPr>
+          <p:cNvPicPr>
+            <a:picLocks noGrp="1" noChangeAspect="1"/>
+          </p:cNvPicPr>
+          <p:nvPr>
+            <p:ph idx="1"/>
+          </p:nvPr>
+        </p:nvPicPr>
+        <p:blipFill>
+          <a:blip r:embed="rId2"/>
+          <a:stretch>
+            <a:fillRect/>
+          </a:stretch>
+        </p:blipFill>
+        <p:spPr>
+          <a:xfrm>
+            <a:off x="230098" y="1690688"/>
+            <a:ext cx="3471982" cy="1401833"/>
+          </a:xfrm>
+          <a:prstGeom prst="rect">
+            <a:avLst/>
+          </a:prstGeom>
+        </p:spPr>
+      </p:pic>
+      <p:pic>
+        <p:nvPicPr>
+          <p:cNvPr id="5" name="Picture 4">
+            <a:extLst>
+              <a:ext uri="{FF2B5EF4-FFF2-40B4-BE49-F238E27FC236}">
+                <a16:creationId xmlns:a16="http://schemas.microsoft.com/office/drawing/2014/main" id="{FC50B3F3-E9C6-0FC6-6C93-D9C1B6C3A0A3}"/>
+              </a:ext>
+            </a:extLst>
+          </p:cNvPr>
+          <p:cNvPicPr>
+            <a:picLocks noChangeAspect="1"/>
+          </p:cNvPicPr>
+          <p:nvPr/>
+        </p:nvPicPr>
+        <p:blipFill>
+          <a:blip r:embed="rId3"/>
+          <a:stretch>
+            <a:fillRect/>
+          </a:stretch>
+        </p:blipFill>
+        <p:spPr>
+          <a:xfrm>
+            <a:off x="3581400" y="2777795"/>
+            <a:ext cx="7772400" cy="3715080"/>
+          </a:xfrm>
+          <a:prstGeom prst="rect">
+            <a:avLst/>
+          </a:prstGeom>
+          <a:solidFill>
+            <a:srgbClr val="FFFFFF">
+              <a:shade val="85000"/>
+            </a:srgbClr>
+          </a:solidFill>
+          <a:ln w="88900" cap="sq">
+            <a:solidFill>
+              <a:srgbClr val="FFFFFF"/>
+            </a:solidFill>
+            <a:miter lim="800000"/>
+          </a:ln>
+          <a:effectLst>
+            <a:outerShdw blurRad="55000" dist="18000" dir="5400000" algn="tl" rotWithShape="0">
+              <a:srgbClr val="000000">
+                <a:alpha val="40000"/>
+              </a:srgbClr>
+            </a:outerShdw>
+          </a:effectLst>
+          <a:scene3d>
+            <a:camera prst="orthographicFront"/>
+            <a:lightRig rig="twoPt" dir="t">
+              <a:rot lat="0" lon="0" rev="7200000"/>
+            </a:lightRig>
+          </a:scene3d>
+          <a:sp3d>
+            <a:bevelT w="25400" h="19050"/>
+            <a:contourClr>
+              <a:srgbClr val="FFFFFF"/>
+            </a:contourClr>
+          </a:sp3d>
+        </p:spPr>
+      </p:pic>
+    </p:spTree>
+    <p:extLst>
+      <p:ext uri="{BB962C8B-B14F-4D97-AF65-F5344CB8AC3E}">
+        <p14:creationId xmlns:p14="http://schemas.microsoft.com/office/powerpoint/2010/main" val="4207058427"/>
       </p:ext>
     </p:extLst>
   </p:cSld>

</xml_diff>